<commit_message>
Update project files and env configuration
</commit_message>
<xml_diff>
--- a/ppt/R24_Community_Project_PPT_Template.pptx
+++ b/ppt/R24_Community_Project_PPT_Template.pptx
@@ -5302,7 +5302,7 @@
                 <a:latin typeface="Times New Roman"/>
                 <a:cs typeface="Times New Roman"/>
               </a:rPr>
-              <a:t>Guide Name: Mrs. N. SowjanyaKumari</a:t>
+              <a:t>Guide Name: k. amaravathi</a:t>
             </a:r>
           </a:p>
           <a:p>
@@ -5311,7 +5311,7 @@
                 <a:latin typeface="Times New Roman"/>
                 <a:cs typeface="Times New Roman"/>
               </a:rPr>
-              <a:t>Designation: Assistant Professor</a:t>
+              <a:t>Designation: assistant professor</a:t>
             </a:r>
           </a:p>
         </p:txBody>
@@ -5349,7 +5349,7 @@
                 <a:latin typeface="Times New Roman"/>
                 <a:cs typeface="Times New Roman"/>
               </a:rPr>
-              <a:t>Project Coordinator: Mrs. N. SowjanyaKumari</a:t>
+              <a:t>Project Coordinator: k. amaravathi</a:t>
             </a:r>
             <a:endParaRPr lang="en-IN" dirty="0">
               <a:latin typeface="Times New Roman" panose="02020603050405020304" pitchFamily="18" charset="0"/>
@@ -5362,7 +5362,7 @@
                 <a:latin typeface="Times New Roman"/>
                 <a:cs typeface="Times New Roman"/>
               </a:rPr>
-              <a:t>Designation: Assistant Professor</a:t>
+              <a:t>Designation: assistant professor</a:t>
             </a:r>
           </a:p>
         </p:txBody>
@@ -5521,7 +5521,7 @@
           <a:lstStyle/>
           <a:p>
             <a:r>
-              <a:rPr lang="en-IN" sz="3600" b="1">
+              <a:rPr lang="en-IN" sz="3600" b="1" dirty="0">
                 <a:latin typeface="Times New Roman"/>
                 <a:cs typeface="Times New Roman"/>
               </a:rPr>
@@ -5553,14 +5553,14 @@
           <a:lstStyle/>
           <a:p>
             <a:r>
-              <a:rPr lang="en-IN" sz="1500" b="1">
-                <a:latin typeface="Times New Roman"/>
-                <a:cs typeface="Times New Roman"/>
-              </a:rPr>
-              <a:t xml:space="preserve">• Modular Design: </a:t>
-            </a:r>
-            <a:r>
-              <a:rPr lang="en-IN" sz="1500">
+              <a:rPr lang="en-IN" sz="1500" b="1" dirty="0">
+                <a:latin typeface="Times New Roman"/>
+                <a:cs typeface="Times New Roman"/>
+              </a:rPr>
+              <a:t xml:space="preserve">Modular Design: </a:t>
+            </a:r>
+            <a:r>
+              <a:rPr lang="en-IN" sz="1500" dirty="0">
                 <a:latin typeface="Times New Roman"/>
                 <a:cs typeface="Times New Roman"/>
               </a:rPr>
@@ -5569,52 +5569,18 @@
           </a:p>
           <a:p>
             <a:r>
-              <a:rPr lang="en-IN" sz="1500" b="1">
-                <a:latin typeface="Times New Roman"/>
-                <a:cs typeface="Times New Roman"/>
-              </a:rPr>
-              <a:t xml:space="preserve">• Block Diagram Code: </a:t>
-            </a:r>
-            <a:r>
-              <a:rPr lang="en-IN" sz="1500">
+              <a:rPr lang="en-IN" sz="1500" b="1" dirty="0">
+                <a:latin typeface="Times New Roman"/>
+                <a:cs typeface="Times New Roman"/>
+              </a:rPr>
+              <a:t xml:space="preserve">Block Diagram Code: </a:t>
+            </a:r>
+            <a:r>
+              <a:rPr lang="en-IN" sz="1500" dirty="0">
                 <a:latin typeface="Times New Roman"/>
                 <a:cs typeface="Times New Roman"/>
               </a:rPr>
               <a:t>See Mermaid structure representing the architectural components:</a:t>
-            </a:r>
-          </a:p>
-          <a:p>
-            <a:r>
-              <a:rPr lang="en-IN" sz="1500" b="1">
-                <a:latin typeface="Times New Roman"/>
-                <a:cs typeface="Times New Roman"/>
-              </a:rPr>
-              <a:t>```mermaid
-</a:t>
-            </a:r>
-            <a:r>
-              <a:rPr lang="en-IN" sz="1500">
-                <a:latin typeface="Times New Roman"/>
-                <a:cs typeface="Times New Roman"/>
-              </a:rPr>
-              <a:t>graph TD
-    subgraph Clients
-        DC[Driver Client] 
-        PC[Passenger Client]
-        AC[Admin Center]
-    end
-    subgraph Flask Backend
-        API[REST APIs] --&gt; GE[GPS Engine]
-        GE --&gt; RM[Route Manager]
-    end
-    subgraph Storage
-        RM --&gt; DB[(SQLite/Postgres)]
-        API &lt;--&gt; Cache[(Live Cache)]
-    end
-    DC --&gt;|Telemetry| API
-    PC &lt;--&gt;|Polling| API
-    AC &lt;--&gt;|Operations| API
-```</a:t>
             </a:r>
           </a:p>
         </p:txBody>
@@ -5716,6 +5682,36 @@
           <a:ln>
             <a:noFill/>
           </a:ln>
+        </p:spPr>
+      </p:pic>
+      <p:pic>
+        <p:nvPicPr>
+          <p:cNvPr id="7" name="Picture 6">
+            <a:extLst>
+              <a:ext uri="{FF2B5EF4-FFF2-40B4-BE49-F238E27FC236}">
+                <a16:creationId xmlns:a16="http://schemas.microsoft.com/office/drawing/2014/main" id="{94892F71-7C09-FF91-00D8-D71BF3F3C498}"/>
+              </a:ext>
+            </a:extLst>
+          </p:cNvPr>
+          <p:cNvPicPr>
+            <a:picLocks noChangeAspect="1"/>
+          </p:cNvPicPr>
+          <p:nvPr/>
+        </p:nvPicPr>
+        <p:blipFill>
+          <a:blip r:embed="rId3"/>
+          <a:stretch>
+            <a:fillRect/>
+          </a:stretch>
+        </p:blipFill>
+        <p:spPr>
+          <a:xfrm>
+            <a:off x="5582525" y="2587752"/>
+            <a:ext cx="2606441" cy="4270248"/>
+          </a:xfrm>
+          <a:prstGeom prst="rect">
+            <a:avLst/>
+          </a:prstGeom>
         </p:spPr>
       </p:pic>
     </p:spTree>
@@ -5806,14 +5802,28 @@
           <a:lstStyle/>
           <a:p>
             <a:r>
-              <a:rPr lang="en-IN" sz="1500" b="1">
-                <a:latin typeface="Times New Roman"/>
-                <a:cs typeface="Times New Roman"/>
-              </a:rPr>
-              <a:t xml:space="preserve">• Admin Command Center: </a:t>
-            </a:r>
-            <a:r>
-              <a:rPr lang="en-IN" sz="1500">
+              <a:rPr lang="en-IN" sz="1500" b="1" dirty="0">
+                <a:latin typeface="Times New Roman"/>
+                <a:cs typeface="Times New Roman"/>
+              </a:rPr>
+              <a:t xml:space="preserve">Admin Command </a:t>
+            </a:r>
+            <a:r>
+              <a:rPr lang="en-IN" sz="1500" b="1" dirty="0" err="1">
+                <a:latin typeface="Times New Roman"/>
+                <a:cs typeface="Times New Roman"/>
+              </a:rPr>
+              <a:t>Center</a:t>
+            </a:r>
+            <a:r>
+              <a:rPr lang="en-IN" sz="1500" b="1" dirty="0">
+                <a:latin typeface="Times New Roman"/>
+                <a:cs typeface="Times New Roman"/>
+              </a:rPr>
+              <a:t xml:space="preserve">: </a:t>
+            </a:r>
+            <a:r>
+              <a:rPr lang="en-IN" sz="1500" dirty="0">
                 <a:latin typeface="Times New Roman"/>
                 <a:cs typeface="Times New Roman"/>
               </a:rPr>
@@ -5822,14 +5832,14 @@
           </a:p>
           <a:p>
             <a:r>
-              <a:rPr lang="en-IN" sz="1500" b="1">
-                <a:latin typeface="Times New Roman"/>
-                <a:cs typeface="Times New Roman"/>
-              </a:rPr>
-              <a:t xml:space="preserve">• Driver Dashboards: </a:t>
-            </a:r>
-            <a:r>
-              <a:rPr lang="en-IN" sz="1500">
+              <a:rPr lang="en-IN" sz="1500" b="1" dirty="0">
+                <a:latin typeface="Times New Roman"/>
+                <a:cs typeface="Times New Roman"/>
+              </a:rPr>
+              <a:t xml:space="preserve">Driver Dashboards: </a:t>
+            </a:r>
+            <a:r>
+              <a:rPr lang="en-IN" sz="1500" dirty="0">
                 <a:latin typeface="Times New Roman"/>
                 <a:cs typeface="Times New Roman"/>
               </a:rPr>
@@ -5838,14 +5848,14 @@
           </a:p>
           <a:p>
             <a:r>
-              <a:rPr lang="en-IN" sz="1500" b="1">
-                <a:latin typeface="Times New Roman"/>
-                <a:cs typeface="Times New Roman"/>
-              </a:rPr>
-              <a:t xml:space="preserve">• Passenger Portal: </a:t>
-            </a:r>
-            <a:r>
-              <a:rPr lang="en-IN" sz="1500">
+              <a:rPr lang="en-IN" sz="1500" b="1" dirty="0">
+                <a:latin typeface="Times New Roman"/>
+                <a:cs typeface="Times New Roman"/>
+              </a:rPr>
+              <a:t xml:space="preserve">Passenger Portal: </a:t>
+            </a:r>
+            <a:r>
+              <a:rPr lang="en-IN" sz="1500" dirty="0">
                 <a:latin typeface="Times New Roman"/>
                 <a:cs typeface="Times New Roman"/>
               </a:rPr>
@@ -5854,18 +5864,46 @@
           </a:p>
           <a:p>
             <a:r>
-              <a:rPr lang="en-IN" sz="1500" b="1">
-                <a:latin typeface="Times New Roman"/>
-                <a:cs typeface="Times New Roman"/>
-              </a:rPr>
-              <a:t xml:space="preserve">• Codebase Repository: </a:t>
-            </a:r>
-            <a:r>
-              <a:rPr lang="en-IN" sz="1500">
-                <a:latin typeface="Times New Roman"/>
-                <a:cs typeface="Times New Roman"/>
-              </a:rPr>
-              <a:t>Built using Flask backend, SQLAlchemy models, and pure LeafletJS/JavaScript client interfaces.</a:t>
+              <a:rPr lang="en-IN" sz="1500" b="1" dirty="0">
+                <a:latin typeface="Times New Roman"/>
+                <a:cs typeface="Times New Roman"/>
+              </a:rPr>
+              <a:t xml:space="preserve">Codebase Repository: </a:t>
+            </a:r>
+            <a:r>
+              <a:rPr lang="en-IN" sz="1500" dirty="0">
+                <a:latin typeface="Times New Roman"/>
+                <a:cs typeface="Times New Roman"/>
+              </a:rPr>
+              <a:t xml:space="preserve">Built using Flask backend, </a:t>
+            </a:r>
+            <a:r>
+              <a:rPr lang="en-IN" sz="1500" dirty="0" err="1">
+                <a:latin typeface="Times New Roman"/>
+                <a:cs typeface="Times New Roman"/>
+              </a:rPr>
+              <a:t>SQLAlchemy</a:t>
+            </a:r>
+            <a:r>
+              <a:rPr lang="en-IN" sz="1500" dirty="0">
+                <a:latin typeface="Times New Roman"/>
+                <a:cs typeface="Times New Roman"/>
+              </a:rPr>
+              <a:t xml:space="preserve"> models, and pure </a:t>
+            </a:r>
+            <a:r>
+              <a:rPr lang="en-IN" sz="1500" dirty="0" err="1">
+                <a:latin typeface="Times New Roman"/>
+                <a:cs typeface="Times New Roman"/>
+              </a:rPr>
+              <a:t>LeafletJS</a:t>
+            </a:r>
+            <a:r>
+              <a:rPr lang="en-IN" sz="1500" dirty="0">
+                <a:latin typeface="Times New Roman"/>
+                <a:cs typeface="Times New Roman"/>
+              </a:rPr>
+              <a:t>/JavaScript client interfaces.</a:t>
             </a:r>
           </a:p>
         </p:txBody>
@@ -6052,14 +6090,28 @@
           <a:lstStyle/>
           <a:p>
             <a:r>
-              <a:rPr lang="en-IN" sz="1500" b="1">
-                <a:latin typeface="Times New Roman"/>
-                <a:cs typeface="Times New Roman"/>
-              </a:rPr>
-              <a:t xml:space="preserve">• Dispatch Center: </a:t>
-            </a:r>
-            <a:r>
-              <a:rPr lang="en-IN" sz="1500">
+              <a:rPr lang="en-IN" sz="1500" b="1" dirty="0">
+                <a:latin typeface="Times New Roman"/>
+                <a:cs typeface="Times New Roman"/>
+              </a:rPr>
+              <a:t xml:space="preserve">Dispatch </a:t>
+            </a:r>
+            <a:r>
+              <a:rPr lang="en-IN" sz="1500" b="1" dirty="0" err="1">
+                <a:latin typeface="Times New Roman"/>
+                <a:cs typeface="Times New Roman"/>
+              </a:rPr>
+              <a:t>Center</a:t>
+            </a:r>
+            <a:r>
+              <a:rPr lang="en-IN" sz="1500" b="1" dirty="0">
+                <a:latin typeface="Times New Roman"/>
+                <a:cs typeface="Times New Roman"/>
+              </a:rPr>
+              <a:t xml:space="preserve">: </a:t>
+            </a:r>
+            <a:r>
+              <a:rPr lang="en-IN" sz="1500" dirty="0">
                 <a:latin typeface="Times New Roman"/>
                 <a:cs typeface="Times New Roman"/>
               </a:rPr>
@@ -6068,14 +6120,14 @@
           </a:p>
           <a:p>
             <a:r>
-              <a:rPr lang="en-IN" sz="1500" b="1">
-                <a:latin typeface="Times New Roman"/>
-                <a:cs typeface="Times New Roman"/>
-              </a:rPr>
-              <a:t xml:space="preserve">• Passenger Timeline: </a:t>
-            </a:r>
-            <a:r>
-              <a:rPr lang="en-IN" sz="1500">
+              <a:rPr lang="en-IN" sz="1500" b="1" dirty="0">
+                <a:latin typeface="Times New Roman"/>
+                <a:cs typeface="Times New Roman"/>
+              </a:rPr>
+              <a:t xml:space="preserve">Passenger Timeline: </a:t>
+            </a:r>
+            <a:r>
+              <a:rPr lang="en-IN" sz="1500" dirty="0">
                 <a:latin typeface="Times New Roman"/>
                 <a:cs typeface="Times New Roman"/>
               </a:rPr>
@@ -6084,30 +6136,44 @@
           </a:p>
           <a:p>
             <a:r>
-              <a:rPr lang="en-IN" sz="1500" b="1">
-                <a:latin typeface="Times New Roman"/>
-                <a:cs typeface="Times New Roman"/>
-              </a:rPr>
-              <a:t xml:space="preserve">• Mobile PWA Prompt: </a:t>
-            </a:r>
-            <a:r>
-              <a:rPr lang="en-IN" sz="1500">
-                <a:latin typeface="Times New Roman"/>
-                <a:cs typeface="Times New Roman"/>
-              </a:rPr>
-              <a:t>Seamless mobile installation trigger allowing users to save TransPulse directly to home screens.</a:t>
-            </a:r>
-          </a:p>
-          <a:p>
-            <a:r>
-              <a:rPr lang="en-IN" sz="1500" b="1">
-                <a:latin typeface="Times New Roman"/>
-                <a:cs typeface="Times New Roman"/>
-              </a:rPr>
-              <a:t xml:space="preserve">• Offline Alert: </a:t>
-            </a:r>
-            <a:r>
-              <a:rPr lang="en-IN" sz="1500">
+              <a:rPr lang="en-IN" sz="1500" b="1" dirty="0">
+                <a:latin typeface="Times New Roman"/>
+                <a:cs typeface="Times New Roman"/>
+              </a:rPr>
+              <a:t xml:space="preserve">Mobile PWA Prompt: </a:t>
+            </a:r>
+            <a:r>
+              <a:rPr lang="en-IN" sz="1500" dirty="0">
+                <a:latin typeface="Times New Roman"/>
+                <a:cs typeface="Times New Roman"/>
+              </a:rPr>
+              <a:t xml:space="preserve">Seamless mobile installation trigger allowing users to save </a:t>
+            </a:r>
+            <a:r>
+              <a:rPr lang="en-IN" sz="1500" dirty="0" err="1">
+                <a:latin typeface="Times New Roman"/>
+                <a:cs typeface="Times New Roman"/>
+              </a:rPr>
+              <a:t>TransPulse</a:t>
+            </a:r>
+            <a:r>
+              <a:rPr lang="en-IN" sz="1500" dirty="0">
+                <a:latin typeface="Times New Roman"/>
+                <a:cs typeface="Times New Roman"/>
+              </a:rPr>
+              <a:t xml:space="preserve"> directly to home screens.</a:t>
+            </a:r>
+          </a:p>
+          <a:p>
+            <a:r>
+              <a:rPr lang="en-IN" sz="1500" b="1" dirty="0">
+                <a:latin typeface="Times New Roman"/>
+                <a:cs typeface="Times New Roman"/>
+              </a:rPr>
+              <a:t xml:space="preserve">Offline Alert: </a:t>
+            </a:r>
+            <a:r>
+              <a:rPr lang="en-IN" sz="1500" dirty="0">
                 <a:latin typeface="Times New Roman"/>
                 <a:cs typeface="Times New Roman"/>
               </a:rPr>
@@ -6298,14 +6364,14 @@
           <a:lstStyle/>
           <a:p>
             <a:r>
-              <a:rPr lang="en-IN" sz="1500" b="1">
-                <a:latin typeface="Times New Roman"/>
-                <a:cs typeface="Times New Roman"/>
-              </a:rPr>
-              <a:t xml:space="preserve">• Technical Impact: </a:t>
-            </a:r>
-            <a:r>
-              <a:rPr lang="en-IN" sz="1500">
+              <a:rPr lang="en-IN" sz="1500" b="1" dirty="0">
+                <a:latin typeface="Times New Roman"/>
+                <a:cs typeface="Times New Roman"/>
+              </a:rPr>
+              <a:t xml:space="preserve">Technical Impact: </a:t>
+            </a:r>
+            <a:r>
+              <a:rPr lang="en-IN" sz="1500" dirty="0">
                 <a:latin typeface="Times New Roman"/>
                 <a:cs typeface="Times New Roman"/>
               </a:rPr>
@@ -6314,14 +6380,14 @@
           </a:p>
           <a:p>
             <a:r>
-              <a:rPr lang="en-IN" sz="1500" b="1">
-                <a:latin typeface="Times New Roman"/>
-                <a:cs typeface="Times New Roman"/>
-              </a:rPr>
-              <a:t xml:space="preserve">• Social Impact: </a:t>
-            </a:r>
-            <a:r>
-              <a:rPr lang="en-IN" sz="1500">
+              <a:rPr lang="en-IN" sz="1500" b="1" dirty="0">
+                <a:latin typeface="Times New Roman"/>
+                <a:cs typeface="Times New Roman"/>
+              </a:rPr>
+              <a:t xml:space="preserve">Social Impact: </a:t>
+            </a:r>
+            <a:r>
+              <a:rPr lang="en-IN" sz="1500" dirty="0">
                 <a:latin typeface="Times New Roman"/>
                 <a:cs typeface="Times New Roman"/>
               </a:rPr>
@@ -6330,14 +6396,14 @@
           </a:p>
           <a:p>
             <a:r>
-              <a:rPr lang="en-IN" sz="1500" b="1">
-                <a:latin typeface="Times New Roman"/>
-                <a:cs typeface="Times New Roman"/>
-              </a:rPr>
-              <a:t xml:space="preserve">• Economic Impact: </a:t>
-            </a:r>
-            <a:r>
-              <a:rPr lang="en-IN" sz="1500">
+              <a:rPr lang="en-IN" sz="1500" b="1" dirty="0">
+                <a:latin typeface="Times New Roman"/>
+                <a:cs typeface="Times New Roman"/>
+              </a:rPr>
+              <a:t xml:space="preserve">Economic Impact: </a:t>
+            </a:r>
+            <a:r>
+              <a:rPr lang="en-IN" sz="1500" dirty="0">
                 <a:latin typeface="Times New Roman"/>
                 <a:cs typeface="Times New Roman"/>
               </a:rPr>
@@ -6528,14 +6594,14 @@
           <a:lstStyle/>
           <a:p>
             <a:r>
-              <a:rPr lang="en-IN" sz="1500" b="1">
-                <a:latin typeface="Times New Roman"/>
-                <a:cs typeface="Times New Roman"/>
-              </a:rPr>
-              <a:t xml:space="preserve">• Telemetry Noise: </a:t>
-            </a:r>
-            <a:r>
-              <a:rPr lang="en-IN" sz="1500">
+              <a:rPr lang="en-IN" sz="1500" b="1" dirty="0">
+                <a:latin typeface="Times New Roman"/>
+                <a:cs typeface="Times New Roman"/>
+              </a:rPr>
+              <a:t xml:space="preserve">Telemetry Noise: </a:t>
+            </a:r>
+            <a:r>
+              <a:rPr lang="en-IN" sz="1500" dirty="0">
                 <a:latin typeface="Times New Roman"/>
                 <a:cs typeface="Times New Roman"/>
               </a:rPr>
@@ -6544,14 +6610,14 @@
           </a:p>
           <a:p>
             <a:r>
-              <a:rPr lang="en-IN" sz="1500" b="1">
-                <a:latin typeface="Times New Roman"/>
-                <a:cs typeface="Times New Roman"/>
-              </a:rPr>
-              <a:t xml:space="preserve">• Dynamic State Reversal: </a:t>
-            </a:r>
-            <a:r>
-              <a:rPr lang="en-IN" sz="1500">
+              <a:rPr lang="en-IN" sz="1500" b="1" dirty="0">
+                <a:latin typeface="Times New Roman"/>
+                <a:cs typeface="Times New Roman"/>
+              </a:rPr>
+              <a:t xml:space="preserve">Dynamic State Reversal: </a:t>
+            </a:r>
+            <a:r>
+              <a:rPr lang="en-IN" sz="1500" dirty="0">
                 <a:latin typeface="Times New Roman"/>
                 <a:cs typeface="Times New Roman"/>
               </a:rPr>
@@ -6560,14 +6626,14 @@
           </a:p>
           <a:p>
             <a:r>
-              <a:rPr lang="en-IN" sz="1500" b="1">
-                <a:latin typeface="Times New Roman"/>
-                <a:cs typeface="Times New Roman"/>
-              </a:rPr>
-              <a:t xml:space="preserve">• Offline Operations: </a:t>
-            </a:r>
-            <a:r>
-              <a:rPr lang="en-IN" sz="1500">
+              <a:rPr lang="en-IN" sz="1500" b="1" dirty="0">
+                <a:latin typeface="Times New Roman"/>
+                <a:cs typeface="Times New Roman"/>
+              </a:rPr>
+              <a:t xml:space="preserve">Offline Operations: </a:t>
+            </a:r>
+            <a:r>
+              <a:rPr lang="en-IN" sz="1500" dirty="0">
                 <a:latin typeface="Times New Roman"/>
                 <a:cs typeface="Times New Roman"/>
               </a:rPr>
@@ -6758,14 +6824,14 @@
           <a:lstStyle/>
           <a:p>
             <a:r>
-              <a:rPr lang="en-IN" sz="1500" b="1">
-                <a:latin typeface="Times New Roman"/>
-                <a:cs typeface="Times New Roman"/>
-              </a:rPr>
-              <a:t xml:space="preserve">• Success: </a:t>
-            </a:r>
-            <a:r>
-              <a:rPr lang="en-IN" sz="1500">
+              <a:rPr lang="en-IN" sz="1500" b="1" dirty="0">
+                <a:latin typeface="Times New Roman"/>
+                <a:cs typeface="Times New Roman"/>
+              </a:rPr>
+              <a:t xml:space="preserve">Success: </a:t>
+            </a:r>
+            <a:r>
+              <a:rPr lang="en-IN" sz="1500" dirty="0">
                 <a:latin typeface="Times New Roman"/>
                 <a:cs typeface="Times New Roman"/>
               </a:rPr>
@@ -6774,14 +6840,14 @@
           </a:p>
           <a:p>
             <a:r>
-              <a:rPr lang="en-IN" sz="1500" b="1">
-                <a:latin typeface="Times New Roman"/>
-                <a:cs typeface="Times New Roman"/>
-              </a:rPr>
-              <a:t xml:space="preserve">• Rigorous Testing: </a:t>
-            </a:r>
-            <a:r>
-              <a:rPr lang="en-IN" sz="1500">
+              <a:rPr lang="en-IN" sz="1500" b="1" dirty="0">
+                <a:latin typeface="Times New Roman"/>
+                <a:cs typeface="Times New Roman"/>
+              </a:rPr>
+              <a:t xml:space="preserve">Rigorous Testing: </a:t>
+            </a:r>
+            <a:r>
+              <a:rPr lang="en-IN" sz="1500" dirty="0">
                 <a:latin typeface="Times New Roman"/>
                 <a:cs typeface="Times New Roman"/>
               </a:rPr>
@@ -6790,14 +6856,14 @@
           </a:p>
           <a:p>
             <a:r>
-              <a:rPr lang="en-IN" sz="1500" b="1">
-                <a:latin typeface="Times New Roman"/>
-                <a:cs typeface="Times New Roman"/>
-              </a:rPr>
-              <a:t xml:space="preserve">• Enterprise Baseline: </a:t>
-            </a:r>
-            <a:r>
-              <a:rPr lang="en-IN" sz="1500">
+              <a:rPr lang="en-IN" sz="1500" b="1" dirty="0">
+                <a:latin typeface="Times New Roman"/>
+                <a:cs typeface="Times New Roman"/>
+              </a:rPr>
+              <a:t xml:space="preserve">Enterprise Baseline: </a:t>
+            </a:r>
+            <a:r>
+              <a:rPr lang="en-IN" sz="1500" dirty="0">
                 <a:latin typeface="Times New Roman"/>
                 <a:cs typeface="Times New Roman"/>
               </a:rPr>
@@ -6988,14 +7054,14 @@
           <a:lstStyle/>
           <a:p>
             <a:r>
-              <a:rPr lang="en-IN" sz="1500" b="1">
-                <a:latin typeface="Times New Roman"/>
-                <a:cs typeface="Times New Roman"/>
-              </a:rPr>
-              <a:t xml:space="preserve">• FCM Push Alerts: </a:t>
-            </a:r>
-            <a:r>
-              <a:rPr lang="en-IN" sz="1500">
+              <a:rPr lang="en-IN" sz="1500" b="1" dirty="0">
+                <a:latin typeface="Times New Roman"/>
+                <a:cs typeface="Times New Roman"/>
+              </a:rPr>
+              <a:t xml:space="preserve">FCM Push Alerts: </a:t>
+            </a:r>
+            <a:r>
+              <a:rPr lang="en-IN" sz="1500" dirty="0">
                 <a:latin typeface="Times New Roman"/>
                 <a:cs typeface="Times New Roman"/>
               </a:rPr>
@@ -7004,14 +7070,14 @@
           </a:p>
           <a:p>
             <a:r>
-              <a:rPr lang="en-IN" sz="1500" b="1">
-                <a:latin typeface="Times New Roman"/>
-                <a:cs typeface="Times New Roman"/>
-              </a:rPr>
-              <a:t xml:space="preserve">• Machine Learning ETAs: </a:t>
-            </a:r>
-            <a:r>
-              <a:rPr lang="en-IN" sz="1500">
+              <a:rPr lang="en-IN" sz="1500" b="1" dirty="0">
+                <a:latin typeface="Times New Roman"/>
+                <a:cs typeface="Times New Roman"/>
+              </a:rPr>
+              <a:t xml:space="preserve">Machine Learning ETAs: </a:t>
+            </a:r>
+            <a:r>
+              <a:rPr lang="en-IN" sz="1500" dirty="0">
                 <a:latin typeface="Times New Roman"/>
                 <a:cs typeface="Times New Roman"/>
               </a:rPr>
@@ -7020,14 +7086,14 @@
           </a:p>
           <a:p>
             <a:r>
-              <a:rPr lang="en-IN" sz="1500" b="1">
-                <a:latin typeface="Times New Roman"/>
-                <a:cs typeface="Times New Roman"/>
-              </a:rPr>
-              <a:t xml:space="preserve">• Eco-Driving Analytics: </a:t>
-            </a:r>
-            <a:r>
-              <a:rPr lang="en-IN" sz="1500">
+              <a:rPr lang="en-IN" sz="1500" b="1" dirty="0">
+                <a:latin typeface="Times New Roman"/>
+                <a:cs typeface="Times New Roman"/>
+              </a:rPr>
+              <a:t xml:space="preserve">Eco-Driving Analytics: </a:t>
+            </a:r>
+            <a:r>
+              <a:rPr lang="en-IN" sz="1500" dirty="0">
                 <a:latin typeface="Times New Roman"/>
                 <a:cs typeface="Times New Roman"/>
               </a:rPr>
@@ -7220,14 +7286,14 @@
           <a:lstStyle/>
           <a:p>
             <a:r>
-              <a:rPr lang="en-IN" sz="1500" b="1">
-                <a:latin typeface="Times New Roman"/>
-                <a:cs typeface="Times New Roman"/>
-              </a:rPr>
-              <a:t xml:space="preserve">• [1] GTFS Standard: </a:t>
-            </a:r>
-            <a:r>
-              <a:rPr lang="en-IN" sz="1500">
+              <a:rPr lang="en-IN" sz="1500" b="1" dirty="0">
+                <a:latin typeface="Times New Roman"/>
+                <a:cs typeface="Times New Roman"/>
+              </a:rPr>
+              <a:t xml:space="preserve">[1] GTFS Standard: </a:t>
+            </a:r>
+            <a:r>
+              <a:rPr lang="en-IN" sz="1500" dirty="0">
                 <a:latin typeface="Times New Roman"/>
                 <a:cs typeface="Times New Roman"/>
               </a:rPr>
@@ -7236,30 +7302,44 @@
           </a:p>
           <a:p>
             <a:r>
-              <a:rPr lang="en-IN" sz="1500" b="1">
-                <a:latin typeface="Times New Roman"/>
-                <a:cs typeface="Times New Roman"/>
-              </a:rPr>
-              <a:t xml:space="preserve">• [2] Web Framework: </a:t>
-            </a:r>
-            <a:r>
-              <a:rPr lang="en-IN" sz="1500">
-                <a:latin typeface="Times New Roman"/>
-                <a:cs typeface="Times New Roman"/>
-              </a:rPr>
-              <a:t>Flask Documentation &amp; Database Orchestration with SQLAlchemy, Pallets Projects, 2026.</a:t>
-            </a:r>
-          </a:p>
-          <a:p>
-            <a:r>
-              <a:rPr lang="en-IN" sz="1500" b="1">
-                <a:latin typeface="Times New Roman"/>
-                <a:cs typeface="Times New Roman"/>
-              </a:rPr>
-              <a:t xml:space="preserve">• [3] Map Rendering: </a:t>
-            </a:r>
-            <a:r>
-              <a:rPr lang="en-IN" sz="1500">
+              <a:rPr lang="en-IN" sz="1500" b="1" dirty="0">
+                <a:latin typeface="Times New Roman"/>
+                <a:cs typeface="Times New Roman"/>
+              </a:rPr>
+              <a:t xml:space="preserve">[2] Web Framework: </a:t>
+            </a:r>
+            <a:r>
+              <a:rPr lang="en-IN" sz="1500" dirty="0">
+                <a:latin typeface="Times New Roman"/>
+                <a:cs typeface="Times New Roman"/>
+              </a:rPr>
+              <a:t xml:space="preserve">Flask Documentation &amp; Database Orchestration with </a:t>
+            </a:r>
+            <a:r>
+              <a:rPr lang="en-IN" sz="1500" dirty="0" err="1">
+                <a:latin typeface="Times New Roman"/>
+                <a:cs typeface="Times New Roman"/>
+              </a:rPr>
+              <a:t>SQLAlchemy</a:t>
+            </a:r>
+            <a:r>
+              <a:rPr lang="en-IN" sz="1500" dirty="0">
+                <a:latin typeface="Times New Roman"/>
+                <a:cs typeface="Times New Roman"/>
+              </a:rPr>
+              <a:t>, Pallets Projects, 2026.</a:t>
+            </a:r>
+          </a:p>
+          <a:p>
+            <a:r>
+              <a:rPr lang="en-IN" sz="1500" b="1" dirty="0">
+                <a:latin typeface="Times New Roman"/>
+                <a:cs typeface="Times New Roman"/>
+              </a:rPr>
+              <a:t xml:space="preserve">[3] Map Rendering: </a:t>
+            </a:r>
+            <a:r>
+              <a:rPr lang="en-IN" sz="1500" dirty="0">
                 <a:latin typeface="Times New Roman"/>
                 <a:cs typeface="Times New Roman"/>
               </a:rPr>
@@ -7268,14 +7348,14 @@
           </a:p>
           <a:p>
             <a:r>
-              <a:rPr lang="en-IN" sz="1500" b="1">
-                <a:latin typeface="Times New Roman"/>
-                <a:cs typeface="Times New Roman"/>
-              </a:rPr>
-              <a:t xml:space="preserve">• [4] Distance Calculations: </a:t>
-            </a:r>
-            <a:r>
-              <a:rPr lang="en-IN" sz="1500">
+              <a:rPr lang="en-IN" sz="1500" b="1" dirty="0">
+                <a:latin typeface="Times New Roman"/>
+                <a:cs typeface="Times New Roman"/>
+              </a:rPr>
+              <a:t xml:space="preserve">[4] Distance Calculations: </a:t>
+            </a:r>
+            <a:r>
+              <a:rPr lang="en-IN" sz="1500" dirty="0">
                 <a:latin typeface="Times New Roman"/>
                 <a:cs typeface="Times New Roman"/>
               </a:rPr>
@@ -7435,30 +7515,37 @@
           <a:lstStyle/>
           <a:p>
             <a:r>
-              <a:rPr lang="en-IN" sz="1500" b="1">
-                <a:latin typeface="Times New Roman"/>
-                <a:cs typeface="Times New Roman"/>
-              </a:rPr>
-              <a:t xml:space="preserve">• Project Name: </a:t>
-            </a:r>
-            <a:r>
-              <a:rPr lang="en-IN" sz="1500">
-                <a:latin typeface="Times New Roman"/>
-                <a:cs typeface="Times New Roman"/>
-              </a:rPr>
-              <a:t>TransPulse: Smart Transit Orchestration Platform</a:t>
-            </a:r>
-          </a:p>
-          <a:p>
-            <a:r>
-              <a:rPr lang="en-IN" sz="1500" b="1">
-                <a:latin typeface="Times New Roman"/>
-                <a:cs typeface="Times New Roman"/>
-              </a:rPr>
-              <a:t xml:space="preserve">• Department: </a:t>
-            </a:r>
-            <a:r>
-              <a:rPr lang="en-IN" sz="1500">
+              <a:rPr lang="en-IN" sz="1500" b="1" dirty="0">
+                <a:latin typeface="Times New Roman"/>
+                <a:cs typeface="Times New Roman"/>
+              </a:rPr>
+              <a:t xml:space="preserve">Project Name: </a:t>
+            </a:r>
+            <a:r>
+              <a:rPr lang="en-IN" sz="1500" dirty="0" err="1">
+                <a:latin typeface="Times New Roman"/>
+                <a:cs typeface="Times New Roman"/>
+              </a:rPr>
+              <a:t>TransPulse</a:t>
+            </a:r>
+            <a:r>
+              <a:rPr lang="en-IN" sz="1500" dirty="0">
+                <a:latin typeface="Times New Roman"/>
+                <a:cs typeface="Times New Roman"/>
+              </a:rPr>
+              <a:t>: Smart Transit Orchestration Platform</a:t>
+            </a:r>
+          </a:p>
+          <a:p>
+            <a:r>
+              <a:rPr lang="en-IN" sz="1500" b="1" dirty="0">
+                <a:latin typeface="Times New Roman"/>
+                <a:cs typeface="Times New Roman"/>
+              </a:rPr>
+              <a:t xml:space="preserve">Department: </a:t>
+            </a:r>
+            <a:r>
+              <a:rPr lang="en-IN" sz="1500" dirty="0">
                 <a:latin typeface="Times New Roman"/>
                 <a:cs typeface="Times New Roman"/>
               </a:rPr>
@@ -7467,30 +7554,65 @@
           </a:p>
           <a:p>
             <a:r>
-              <a:rPr lang="en-IN" sz="1500" b="1">
-                <a:latin typeface="Times New Roman"/>
-                <a:cs typeface="Times New Roman"/>
-              </a:rPr>
-              <a:t xml:space="preserve">• Team Members: </a:t>
-            </a:r>
-            <a:r>
-              <a:rPr lang="en-IN" sz="1500">
-                <a:latin typeface="Times New Roman"/>
-                <a:cs typeface="Times New Roman"/>
-              </a:rPr>
-              <a:t>Bendi Rajesh, Matha Vignan Vamsi, Kudupudi Lakshmi Vinay, Gurala Sravan Kumar</a:t>
-            </a:r>
-          </a:p>
-          <a:p>
-            <a:r>
-              <a:rPr lang="en-IN" sz="1500" b="1">
-                <a:latin typeface="Times New Roman"/>
-                <a:cs typeface="Times New Roman"/>
-              </a:rPr>
-              <a:t xml:space="preserve">• Thank You: </a:t>
-            </a:r>
-            <a:r>
-              <a:rPr lang="en-IN" sz="1500">
+              <a:rPr lang="en-IN" sz="1500" b="1" dirty="0">
+                <a:latin typeface="Times New Roman"/>
+                <a:cs typeface="Times New Roman"/>
+              </a:rPr>
+              <a:t xml:space="preserve">Team Members: </a:t>
+            </a:r>
+            <a:r>
+              <a:rPr lang="en-IN" sz="1500" dirty="0" err="1">
+                <a:latin typeface="Times New Roman"/>
+                <a:cs typeface="Times New Roman"/>
+              </a:rPr>
+              <a:t>Bendi</a:t>
+            </a:r>
+            <a:r>
+              <a:rPr lang="en-IN" sz="1500" dirty="0">
+                <a:latin typeface="Times New Roman"/>
+                <a:cs typeface="Times New Roman"/>
+              </a:rPr>
+              <a:t xml:space="preserve"> Rajesh, Matha Vignan Vamsi, </a:t>
+            </a:r>
+            <a:r>
+              <a:rPr lang="en-IN" sz="1500" dirty="0" err="1">
+                <a:latin typeface="Times New Roman"/>
+                <a:cs typeface="Times New Roman"/>
+              </a:rPr>
+              <a:t>Kudupudi</a:t>
+            </a:r>
+            <a:r>
+              <a:rPr lang="en-IN" sz="1500" dirty="0">
+                <a:latin typeface="Times New Roman"/>
+                <a:cs typeface="Times New Roman"/>
+              </a:rPr>
+              <a:t xml:space="preserve"> Lakshmi Vinay, </a:t>
+            </a:r>
+            <a:r>
+              <a:rPr lang="en-IN" sz="1500" dirty="0" err="1">
+                <a:latin typeface="Times New Roman"/>
+                <a:cs typeface="Times New Roman"/>
+              </a:rPr>
+              <a:t>Gurala</a:t>
+            </a:r>
+            <a:r>
+              <a:rPr lang="en-IN" sz="1500" dirty="0">
+                <a:latin typeface="Times New Roman"/>
+                <a:cs typeface="Times New Roman"/>
+              </a:rPr>
+              <a:t xml:space="preserve"> Sravan Kumar</a:t>
+            </a:r>
+          </a:p>
+          <a:p>
+            <a:r>
+              <a:rPr lang="en-IN" sz="1500" b="1" dirty="0">
+                <a:latin typeface="Times New Roman"/>
+                <a:cs typeface="Times New Roman"/>
+              </a:rPr>
+              <a:t xml:space="preserve">Thank You: </a:t>
+            </a:r>
+            <a:r>
+              <a:rPr lang="en-IN" sz="1500" dirty="0">
                 <a:latin typeface="Times New Roman"/>
                 <a:cs typeface="Times New Roman"/>
               </a:rPr>
@@ -7681,14 +7803,14 @@
           <a:lstStyle/>
           <a:p>
             <a:r>
-              <a:rPr lang="en-IN" sz="1500" b="1">
-                <a:latin typeface="Times New Roman"/>
-                <a:cs typeface="Times New Roman"/>
-              </a:rPr>
-              <a:t xml:space="preserve">• Context: </a:t>
-            </a:r>
-            <a:r>
-              <a:rPr lang="en-IN" sz="1500">
+              <a:rPr lang="en-IN" sz="1500" b="1" dirty="0">
+                <a:latin typeface="Times New Roman"/>
+                <a:cs typeface="Times New Roman"/>
+              </a:rPr>
+              <a:t xml:space="preserve">Context: </a:t>
+            </a:r>
+            <a:r>
+              <a:rPr lang="en-IN" sz="1500" dirty="0">
                 <a:latin typeface="Times New Roman"/>
                 <a:cs typeface="Times New Roman"/>
               </a:rPr>
@@ -7697,30 +7819,37 @@
           </a:p>
           <a:p>
             <a:r>
-              <a:rPr lang="en-IN" sz="1500" b="1">
-                <a:latin typeface="Times New Roman"/>
-                <a:cs typeface="Times New Roman"/>
-              </a:rPr>
-              <a:t xml:space="preserve">• Platform: </a:t>
-            </a:r>
-            <a:r>
-              <a:rPr lang="en-IN" sz="1500">
-                <a:latin typeface="Times New Roman"/>
-                <a:cs typeface="Times New Roman"/>
-              </a:rPr>
-              <a:t>TransPulse is a production-grade mobility platform that connects passengers, drivers, and administrators.</a:t>
-            </a:r>
-          </a:p>
-          <a:p>
-            <a:r>
-              <a:rPr lang="en-IN" sz="1500" b="1">
-                <a:latin typeface="Times New Roman"/>
-                <a:cs typeface="Times New Roman"/>
-              </a:rPr>
-              <a:t xml:space="preserve">• Backend Integration: </a:t>
-            </a:r>
-            <a:r>
-              <a:rPr lang="en-IN" sz="1500">
+              <a:rPr lang="en-IN" sz="1500" b="1" dirty="0">
+                <a:latin typeface="Times New Roman"/>
+                <a:cs typeface="Times New Roman"/>
+              </a:rPr>
+              <a:t xml:space="preserve">Platform: </a:t>
+            </a:r>
+            <a:r>
+              <a:rPr lang="en-IN" sz="1500" dirty="0" err="1">
+                <a:latin typeface="Times New Roman"/>
+                <a:cs typeface="Times New Roman"/>
+              </a:rPr>
+              <a:t>TransPulse</a:t>
+            </a:r>
+            <a:r>
+              <a:rPr lang="en-IN" sz="1500" dirty="0">
+                <a:latin typeface="Times New Roman"/>
+                <a:cs typeface="Times New Roman"/>
+              </a:rPr>
+              <a:t xml:space="preserve"> is a production-grade mobility platform that connects passengers, drivers, and administrators.</a:t>
+            </a:r>
+          </a:p>
+          <a:p>
+            <a:r>
+              <a:rPr lang="en-IN" sz="1500" b="1" dirty="0">
+                <a:latin typeface="Times New Roman"/>
+                <a:cs typeface="Times New Roman"/>
+              </a:rPr>
+              <a:t xml:space="preserve">Backend Integration: </a:t>
+            </a:r>
+            <a:r>
+              <a:rPr lang="en-IN" sz="1500" dirty="0">
                 <a:latin typeface="Times New Roman"/>
                 <a:cs typeface="Times New Roman"/>
               </a:rPr>
@@ -7729,30 +7858,44 @@
           </a:p>
           <a:p>
             <a:r>
-              <a:rPr lang="en-IN" sz="1500" b="1">
-                <a:latin typeface="Times New Roman"/>
-                <a:cs typeface="Times New Roman"/>
-              </a:rPr>
-              <a:t xml:space="preserve">• Key Engine: </a:t>
-            </a:r>
-            <a:r>
-              <a:rPr lang="en-IN" sz="1500">
-                <a:latin typeface="Times New Roman"/>
-                <a:cs typeface="Times New Roman"/>
-              </a:rPr>
-              <a:t>Employs geodetic stop-progression calculations and smoothed speed formulas for robust delay modeling.</a:t>
-            </a:r>
-          </a:p>
-          <a:p>
-            <a:r>
-              <a:rPr lang="en-IN" sz="1500" b="1">
-                <a:latin typeface="Times New Roman"/>
-                <a:cs typeface="Times New Roman"/>
-              </a:rPr>
-              <a:t xml:space="preserve">• Offline Support: </a:t>
-            </a:r>
-            <a:r>
-              <a:rPr lang="en-IN" sz="1500">
+              <a:rPr lang="en-IN" sz="1500" b="1" dirty="0">
+                <a:latin typeface="Times New Roman"/>
+                <a:cs typeface="Times New Roman"/>
+              </a:rPr>
+              <a:t xml:space="preserve">Key Engine: </a:t>
+            </a:r>
+            <a:r>
+              <a:rPr lang="en-IN" sz="1500" dirty="0">
+                <a:latin typeface="Times New Roman"/>
+                <a:cs typeface="Times New Roman"/>
+              </a:rPr>
+              <a:t xml:space="preserve">Employs geodetic stop-progression calculations and smoothed speed formulas for robust delay </a:t>
+            </a:r>
+            <a:r>
+              <a:rPr lang="en-IN" sz="1500" dirty="0" err="1">
+                <a:latin typeface="Times New Roman"/>
+                <a:cs typeface="Times New Roman"/>
+              </a:rPr>
+              <a:t>modeling</a:t>
+            </a:r>
+            <a:r>
+              <a:rPr lang="en-IN" sz="1500" dirty="0">
+                <a:latin typeface="Times New Roman"/>
+                <a:cs typeface="Times New Roman"/>
+              </a:rPr>
+              <a:t>.</a:t>
+            </a:r>
+          </a:p>
+          <a:p>
+            <a:r>
+              <a:rPr lang="en-IN" sz="1500" b="1" dirty="0">
+                <a:latin typeface="Times New Roman"/>
+                <a:cs typeface="Times New Roman"/>
+              </a:rPr>
+              <a:t xml:space="preserve">Offline Support: </a:t>
+            </a:r>
+            <a:r>
+              <a:rPr lang="en-IN" sz="1500" dirty="0">
                 <a:latin typeface="Times New Roman"/>
                 <a:cs typeface="Times New Roman"/>
               </a:rPr>
@@ -7943,14 +8086,14 @@
           <a:lstStyle/>
           <a:p>
             <a:r>
-              <a:rPr lang="en-IN" sz="1500" b="1">
-                <a:latin typeface="Times New Roman"/>
-                <a:cs typeface="Times New Roman"/>
-              </a:rPr>
-              <a:t xml:space="preserve">• Modern Smart Transit: </a:t>
-            </a:r>
-            <a:r>
-              <a:rPr lang="en-IN" sz="1500">
+              <a:rPr lang="en-IN" sz="1500" b="1" dirty="0">
+                <a:latin typeface="Times New Roman"/>
+                <a:cs typeface="Times New Roman"/>
+              </a:rPr>
+              <a:t xml:space="preserve">Modern Smart Transit: </a:t>
+            </a:r>
+            <a:r>
+              <a:rPr lang="en-IN" sz="1500" dirty="0">
                 <a:latin typeface="Times New Roman"/>
                 <a:cs typeface="Times New Roman"/>
               </a:rPr>
@@ -7959,14 +8102,14 @@
           </a:p>
           <a:p>
             <a:r>
-              <a:rPr lang="en-IN" sz="1500" b="1">
-                <a:latin typeface="Times New Roman"/>
-                <a:cs typeface="Times New Roman"/>
-              </a:rPr>
-              <a:t xml:space="preserve">• Unified Platform: </a:t>
-            </a:r>
-            <a:r>
-              <a:rPr lang="en-IN" sz="1500">
+              <a:rPr lang="en-IN" sz="1500" b="1" dirty="0">
+                <a:latin typeface="Times New Roman"/>
+                <a:cs typeface="Times New Roman"/>
+              </a:rPr>
+              <a:t xml:space="preserve">Unified Platform: </a:t>
+            </a:r>
+            <a:r>
+              <a:rPr lang="en-IN" sz="1500" dirty="0">
                 <a:latin typeface="Times New Roman"/>
                 <a:cs typeface="Times New Roman"/>
               </a:rPr>
@@ -7975,30 +8118,30 @@
           </a:p>
           <a:p>
             <a:r>
-              <a:rPr lang="en-IN" sz="1500" b="1">
-                <a:latin typeface="Times New Roman"/>
-                <a:cs typeface="Times New Roman"/>
-              </a:rPr>
-              <a:t xml:space="preserve">• AP Smart Mobility: </a:t>
-            </a:r>
-            <a:r>
-              <a:rPr lang="en-IN" sz="1500">
-                <a:latin typeface="Times New Roman"/>
-                <a:cs typeface="Times New Roman"/>
-              </a:rPr>
-              <a:t>Tailored to Andhra Pradesh geography covering 26 districts and 100+ active routes.</a:t>
-            </a:r>
-          </a:p>
-          <a:p>
-            <a:r>
-              <a:rPr lang="en-IN" sz="1500" b="1">
-                <a:latin typeface="Times New Roman"/>
-                <a:cs typeface="Times New Roman"/>
-              </a:rPr>
-              <a:t xml:space="preserve">• Centralized Orchestration: </a:t>
-            </a:r>
-            <a:r>
-              <a:rPr lang="en-IN" sz="1500">
+              <a:rPr lang="en-IN" sz="1500" b="1" dirty="0">
+                <a:latin typeface="Times New Roman"/>
+                <a:cs typeface="Times New Roman"/>
+              </a:rPr>
+              <a:t xml:space="preserve">AP Smart Mobility: </a:t>
+            </a:r>
+            <a:r>
+              <a:rPr lang="en-IN" sz="1500" dirty="0">
+                <a:latin typeface="Times New Roman"/>
+                <a:cs typeface="Times New Roman"/>
+              </a:rPr>
+              <a:t>Tailored to Andhra Pradesh geography covering 26 districts and 8000+ active routes.</a:t>
+            </a:r>
+          </a:p>
+          <a:p>
+            <a:r>
+              <a:rPr lang="en-IN" sz="1500" b="1" dirty="0">
+                <a:latin typeface="Times New Roman"/>
+                <a:cs typeface="Times New Roman"/>
+              </a:rPr>
+              <a:t xml:space="preserve">Centralized Orchestration: </a:t>
+            </a:r>
+            <a:r>
+              <a:rPr lang="en-IN" sz="1500" dirty="0">
                 <a:latin typeface="Times New Roman"/>
                 <a:cs typeface="Times New Roman"/>
               </a:rPr>
@@ -8189,14 +8332,14 @@
           <a:lstStyle/>
           <a:p>
             <a:r>
-              <a:rPr lang="en-IN" sz="1500" b="1">
-                <a:latin typeface="Times New Roman"/>
-                <a:cs typeface="Times New Roman"/>
-              </a:rPr>
-              <a:t xml:space="preserve">• Commuter Uncertainty: </a:t>
-            </a:r>
-            <a:r>
-              <a:rPr lang="en-IN" sz="1500">
+              <a:rPr lang="en-IN" sz="1500" b="1" dirty="0">
+                <a:latin typeface="Times New Roman"/>
+                <a:cs typeface="Times New Roman"/>
+              </a:rPr>
+              <a:t xml:space="preserve">Commuter Uncertainty: </a:t>
+            </a:r>
+            <a:r>
+              <a:rPr lang="en-IN" sz="1500" dirty="0">
                 <a:latin typeface="Times New Roman"/>
                 <a:cs typeface="Times New Roman"/>
               </a:rPr>
@@ -8205,14 +8348,14 @@
           </a:p>
           <a:p>
             <a:r>
-              <a:rPr lang="en-IN" sz="1500" b="1">
-                <a:latin typeface="Times New Roman"/>
-                <a:cs typeface="Times New Roman"/>
-              </a:rPr>
-              <a:t xml:space="preserve">• Erratic Telemetry: </a:t>
-            </a:r>
-            <a:r>
-              <a:rPr lang="en-IN" sz="1500">
+              <a:rPr lang="en-IN" sz="1500" b="1" dirty="0">
+                <a:latin typeface="Times New Roman"/>
+                <a:cs typeface="Times New Roman"/>
+              </a:rPr>
+              <a:t xml:space="preserve">Erratic Telemetry: </a:t>
+            </a:r>
+            <a:r>
+              <a:rPr lang="en-IN" sz="1500" dirty="0">
                 <a:latin typeface="Times New Roman"/>
                 <a:cs typeface="Times New Roman"/>
               </a:rPr>
@@ -8221,14 +8364,14 @@
           </a:p>
           <a:p>
             <a:r>
-              <a:rPr lang="en-IN" sz="1500" b="1">
-                <a:latin typeface="Times New Roman"/>
-                <a:cs typeface="Times New Roman"/>
-              </a:rPr>
-              <a:t xml:space="preserve">• Outdated ETA Math: </a:t>
-            </a:r>
-            <a:r>
-              <a:rPr lang="en-IN" sz="1500">
+              <a:rPr lang="en-IN" sz="1500" b="1" dirty="0">
+                <a:latin typeface="Times New Roman"/>
+                <a:cs typeface="Times New Roman"/>
+              </a:rPr>
+              <a:t xml:space="preserve">Outdated ETA Math: </a:t>
+            </a:r>
+            <a:r>
+              <a:rPr lang="en-IN" sz="1500" dirty="0">
                 <a:latin typeface="Times New Roman"/>
                 <a:cs typeface="Times New Roman"/>
               </a:rPr>
@@ -8237,14 +8380,14 @@
           </a:p>
           <a:p>
             <a:r>
-              <a:rPr lang="en-IN" sz="1500" b="1">
-                <a:latin typeface="Times New Roman"/>
-                <a:cs typeface="Times New Roman"/>
-              </a:rPr>
-              <a:t xml:space="preserve">• Isolated Workflows: </a:t>
-            </a:r>
-            <a:r>
-              <a:rPr lang="en-IN" sz="1500">
+              <a:rPr lang="en-IN" sz="1500" b="1" dirty="0">
+                <a:latin typeface="Times New Roman"/>
+                <a:cs typeface="Times New Roman"/>
+              </a:rPr>
+              <a:t xml:space="preserve">Isolated Workflows: </a:t>
+            </a:r>
+            <a:r>
+              <a:rPr lang="en-IN" sz="1500" dirty="0">
                 <a:latin typeface="Times New Roman"/>
                 <a:cs typeface="Times New Roman"/>
               </a:rPr>
@@ -8435,14 +8578,14 @@
           <a:lstStyle/>
           <a:p>
             <a:r>
-              <a:rPr lang="en-IN" sz="1500" b="1">
-                <a:latin typeface="Times New Roman"/>
-                <a:cs typeface="Times New Roman"/>
-              </a:rPr>
-              <a:t xml:space="preserve">• Real-Time Map Tracking: </a:t>
-            </a:r>
-            <a:r>
-              <a:rPr lang="en-IN" sz="1500">
+              <a:rPr lang="en-IN" sz="1500" b="1" dirty="0">
+                <a:latin typeface="Times New Roman"/>
+                <a:cs typeface="Times New Roman"/>
+              </a:rPr>
+              <a:t xml:space="preserve">Real-Time Map Tracking: </a:t>
+            </a:r>
+            <a:r>
+              <a:rPr lang="en-IN" sz="1500" dirty="0">
                 <a:latin typeface="Times New Roman"/>
                 <a:cs typeface="Times New Roman"/>
               </a:rPr>
@@ -8451,14 +8594,14 @@
           </a:p>
           <a:p>
             <a:r>
-              <a:rPr lang="en-IN" sz="1500" b="1">
-                <a:latin typeface="Times New Roman"/>
-                <a:cs typeface="Times New Roman"/>
-              </a:rPr>
-              <a:t xml:space="preserve">• Monotonic Checkpoints: </a:t>
-            </a:r>
-            <a:r>
-              <a:rPr lang="en-IN" sz="1500">
+              <a:rPr lang="en-IN" sz="1500" b="1" dirty="0">
+                <a:latin typeface="Times New Roman"/>
+                <a:cs typeface="Times New Roman"/>
+              </a:rPr>
+              <a:t xml:space="preserve">Monotonic Checkpoints: </a:t>
+            </a:r>
+            <a:r>
+              <a:rPr lang="en-IN" sz="1500" dirty="0">
                 <a:latin typeface="Times New Roman"/>
                 <a:cs typeface="Times New Roman"/>
               </a:rPr>
@@ -8467,14 +8610,14 @@
           </a:p>
           <a:p>
             <a:r>
-              <a:rPr lang="en-IN" sz="1500" b="1">
-                <a:latin typeface="Times New Roman"/>
-                <a:cs typeface="Times New Roman"/>
-              </a:rPr>
-              <a:t xml:space="preserve">• Dynamic ETA Projections: </a:t>
-            </a:r>
-            <a:r>
-              <a:rPr lang="en-IN" sz="1500">
+              <a:rPr lang="en-IN" sz="1500" b="1" dirty="0">
+                <a:latin typeface="Times New Roman"/>
+                <a:cs typeface="Times New Roman"/>
+              </a:rPr>
+              <a:t xml:space="preserve">Dynamic ETA Projections: </a:t>
+            </a:r>
+            <a:r>
+              <a:rPr lang="en-IN" sz="1500" dirty="0">
                 <a:latin typeface="Times New Roman"/>
                 <a:cs typeface="Times New Roman"/>
               </a:rPr>
@@ -8483,14 +8626,28 @@
           </a:p>
           <a:p>
             <a:r>
-              <a:rPr lang="en-IN" sz="1500" b="1">
-                <a:latin typeface="Times New Roman"/>
-                <a:cs typeface="Times New Roman"/>
-              </a:rPr>
-              <a:t xml:space="preserve">• App Installability: </a:t>
-            </a:r>
-            <a:r>
-              <a:rPr lang="en-IN" sz="1500">
+              <a:rPr lang="en-IN" sz="1500" b="1" dirty="0">
+                <a:latin typeface="Times New Roman"/>
+                <a:cs typeface="Times New Roman"/>
+              </a:rPr>
+              <a:t xml:space="preserve">App </a:t>
+            </a:r>
+            <a:r>
+              <a:rPr lang="en-IN" sz="1500" b="1" dirty="0" err="1">
+                <a:latin typeface="Times New Roman"/>
+                <a:cs typeface="Times New Roman"/>
+              </a:rPr>
+              <a:t>Installability</a:t>
+            </a:r>
+            <a:r>
+              <a:rPr lang="en-IN" sz="1500" b="1" dirty="0">
+                <a:latin typeface="Times New Roman"/>
+                <a:cs typeface="Times New Roman"/>
+              </a:rPr>
+              <a:t xml:space="preserve">: </a:t>
+            </a:r>
+            <a:r>
+              <a:rPr lang="en-IN" sz="1500" dirty="0">
                 <a:latin typeface="Times New Roman"/>
                 <a:cs typeface="Times New Roman"/>
               </a:rPr>
@@ -8681,30 +8838,44 @@
           <a:lstStyle/>
           <a:p>
             <a:r>
-              <a:rPr lang="en-IN" sz="1500" b="1">
-                <a:latin typeface="Times New Roman"/>
-                <a:cs typeface="Times New Roman"/>
-              </a:rPr>
-              <a:t xml:space="preserve">• Regional Network: </a:t>
-            </a:r>
-            <a:r>
-              <a:rPr lang="en-IN" sz="1500">
-                <a:latin typeface="Times New Roman"/>
-                <a:cs typeface="Times New Roman"/>
-              </a:rPr>
-              <a:t>Designed for Andhra Pradesh transit operations, centered around the Palasa regional hub.</a:t>
-            </a:r>
-          </a:p>
-          <a:p>
-            <a:r>
-              <a:rPr lang="en-IN" sz="1500" b="1">
-                <a:latin typeface="Times New Roman"/>
-                <a:cs typeface="Times New Roman"/>
-              </a:rPr>
-              <a:t xml:space="preserve">• Comprehensive Routing: </a:t>
-            </a:r>
-            <a:r>
-              <a:rPr lang="en-IN" sz="1500">
+              <a:rPr lang="en-IN" sz="1500" b="1" dirty="0">
+                <a:latin typeface="Times New Roman"/>
+                <a:cs typeface="Times New Roman"/>
+              </a:rPr>
+              <a:t xml:space="preserve">Regional Network: </a:t>
+            </a:r>
+            <a:r>
+              <a:rPr lang="en-IN" sz="1500" dirty="0">
+                <a:latin typeface="Times New Roman"/>
+                <a:cs typeface="Times New Roman"/>
+              </a:rPr>
+              <a:t xml:space="preserve">Designed for Andhra Pradesh transit operations, </a:t>
+            </a:r>
+            <a:r>
+              <a:rPr lang="en-IN" sz="1500" dirty="0" err="1">
+                <a:latin typeface="Times New Roman"/>
+                <a:cs typeface="Times New Roman"/>
+              </a:rPr>
+              <a:t>centered</a:t>
+            </a:r>
+            <a:r>
+              <a:rPr lang="en-IN" sz="1500" dirty="0">
+                <a:latin typeface="Times New Roman"/>
+                <a:cs typeface="Times New Roman"/>
+              </a:rPr>
+              <a:t xml:space="preserve"> around the Palasa regional hub.</a:t>
+            </a:r>
+          </a:p>
+          <a:p>
+            <a:r>
+              <a:rPr lang="en-IN" sz="1500" b="1" dirty="0">
+                <a:latin typeface="Times New Roman"/>
+                <a:cs typeface="Times New Roman"/>
+              </a:rPr>
+              <a:t xml:space="preserve">Comprehensive Routing: </a:t>
+            </a:r>
+            <a:r>
+              <a:rPr lang="en-IN" sz="1500" dirty="0">
                 <a:latin typeface="Times New Roman"/>
                 <a:cs typeface="Times New Roman"/>
               </a:rPr>
@@ -8713,14 +8884,14 @@
           </a:p>
           <a:p>
             <a:r>
-              <a:rPr lang="en-IN" sz="1500" b="1">
-                <a:latin typeface="Times New Roman"/>
-                <a:cs typeface="Times New Roman"/>
-              </a:rPr>
-              <a:t xml:space="preserve">• Fleet Orchestration: </a:t>
-            </a:r>
-            <a:r>
-              <a:rPr lang="en-IN" sz="1500">
+              <a:rPr lang="en-IN" sz="1500" b="1" dirty="0">
+                <a:latin typeface="Times New Roman"/>
+                <a:cs typeface="Times New Roman"/>
+              </a:rPr>
+              <a:t xml:space="preserve">Fleet Orchestration: </a:t>
+            </a:r>
+            <a:r>
+              <a:rPr lang="en-IN" sz="1500" dirty="0">
                 <a:latin typeface="Times New Roman"/>
                 <a:cs typeface="Times New Roman"/>
               </a:rPr>
@@ -8729,14 +8900,14 @@
           </a:p>
           <a:p>
             <a:r>
-              <a:rPr lang="en-IN" sz="1500" b="1">
-                <a:latin typeface="Times New Roman"/>
-                <a:cs typeface="Times New Roman"/>
-              </a:rPr>
-              <a:t xml:space="preserve">• Layered Map Fallbacks: </a:t>
-            </a:r>
-            <a:r>
-              <a:rPr lang="en-IN" sz="1500">
+              <a:rPr lang="en-IN" sz="1500" b="1" dirty="0">
+                <a:latin typeface="Times New Roman"/>
+                <a:cs typeface="Times New Roman"/>
+              </a:rPr>
+              <a:t xml:space="preserve">Layered Map Fallbacks: </a:t>
+            </a:r>
+            <a:r>
+              <a:rPr lang="en-IN" sz="1500" dirty="0">
                 <a:latin typeface="Times New Roman"/>
                 <a:cs typeface="Times New Roman"/>
               </a:rPr>
@@ -8927,14 +9098,14 @@
           <a:lstStyle/>
           <a:p>
             <a:r>
-              <a:rPr lang="en-IN" sz="1500" b="1">
-                <a:latin typeface="Times New Roman"/>
-                <a:cs typeface="Times New Roman"/>
-              </a:rPr>
-              <a:t xml:space="preserve">• Legacy Tracking Systems: </a:t>
-            </a:r>
-            <a:r>
-              <a:rPr lang="en-IN" sz="1500">
+              <a:rPr lang="en-IN" sz="1500" b="1" dirty="0">
+                <a:latin typeface="Times New Roman"/>
+                <a:cs typeface="Times New Roman"/>
+              </a:rPr>
+              <a:t xml:space="preserve">Legacy Tracking Systems: </a:t>
+            </a:r>
+            <a:r>
+              <a:rPr lang="en-IN" sz="1500" dirty="0">
                 <a:latin typeface="Times New Roman"/>
                 <a:cs typeface="Times New Roman"/>
               </a:rPr>
@@ -8943,14 +9114,14 @@
           </a:p>
           <a:p>
             <a:r>
-              <a:rPr lang="en-IN" sz="1500" b="1">
-                <a:latin typeface="Times New Roman"/>
-                <a:cs typeface="Times New Roman"/>
-              </a:rPr>
-              <a:t xml:space="preserve">• Static GTFS Constraints: </a:t>
-            </a:r>
-            <a:r>
-              <a:rPr lang="en-IN" sz="1500">
+              <a:rPr lang="en-IN" sz="1500" b="1" dirty="0">
+                <a:latin typeface="Times New Roman"/>
+                <a:cs typeface="Times New Roman"/>
+              </a:rPr>
+              <a:t xml:space="preserve">Static GTFS Constraints: </a:t>
+            </a:r>
+            <a:r>
+              <a:rPr lang="en-IN" sz="1500" dirty="0">
                 <a:latin typeface="Times New Roman"/>
                 <a:cs typeface="Times New Roman"/>
               </a:rPr>
@@ -8959,14 +9130,14 @@
           </a:p>
           <a:p>
             <a:r>
-              <a:rPr lang="en-IN" sz="1500" b="1">
-                <a:latin typeface="Times New Roman"/>
-                <a:cs typeface="Times New Roman"/>
-              </a:rPr>
-              <a:t xml:space="preserve">• Modern Smart Platforms: </a:t>
-            </a:r>
-            <a:r>
-              <a:rPr lang="en-IN" sz="1500">
+              <a:rPr lang="en-IN" sz="1500" b="1" dirty="0">
+                <a:latin typeface="Times New Roman"/>
+                <a:cs typeface="Times New Roman"/>
+              </a:rPr>
+              <a:t xml:space="preserve">Modern Smart Platforms: </a:t>
+            </a:r>
+            <a:r>
+              <a:rPr lang="en-IN" sz="1500" dirty="0">
                 <a:latin typeface="Times New Roman"/>
                 <a:cs typeface="Times New Roman"/>
               </a:rPr>
@@ -8975,14 +9146,21 @@
           </a:p>
           <a:p>
             <a:r>
-              <a:rPr lang="en-IN" sz="1500" b="1">
-                <a:latin typeface="Times New Roman"/>
-                <a:cs typeface="Times New Roman"/>
-              </a:rPr>
-              <a:t xml:space="preserve">• TransPulse Edge: </a:t>
-            </a:r>
-            <a:r>
-              <a:rPr lang="en-IN" sz="1500">
+              <a:rPr lang="en-IN" sz="1500" b="1" dirty="0" err="1">
+                <a:latin typeface="Times New Roman"/>
+                <a:cs typeface="Times New Roman"/>
+              </a:rPr>
+              <a:t>TransPulse</a:t>
+            </a:r>
+            <a:r>
+              <a:rPr lang="en-IN" sz="1500" b="1" dirty="0">
+                <a:latin typeface="Times New Roman"/>
+                <a:cs typeface="Times New Roman"/>
+              </a:rPr>
+              <a:t xml:space="preserve"> Edge: </a:t>
+            </a:r>
+            <a:r>
+              <a:rPr lang="en-IN" sz="1500" dirty="0">
                 <a:latin typeface="Times New Roman"/>
                 <a:cs typeface="Times New Roman"/>
               </a:rPr>
@@ -9173,14 +9351,14 @@
           <a:lstStyle/>
           <a:p>
             <a:r>
-              <a:rPr lang="en-IN" sz="1500" b="1">
-                <a:latin typeface="Times New Roman"/>
-                <a:cs typeface="Times New Roman"/>
-              </a:rPr>
-              <a:t xml:space="preserve">• Static Schedule Database: </a:t>
-            </a:r>
-            <a:r>
-              <a:rPr lang="en-IN" sz="1500">
+              <a:rPr lang="en-IN" sz="1500" b="1" dirty="0">
+                <a:latin typeface="Times New Roman"/>
+                <a:cs typeface="Times New Roman"/>
+              </a:rPr>
+              <a:t xml:space="preserve">Static Schedule Database: </a:t>
+            </a:r>
+            <a:r>
+              <a:rPr lang="en-IN" sz="1500" dirty="0">
                 <a:latin typeface="Times New Roman"/>
                 <a:cs typeface="Times New Roman"/>
               </a:rPr>
@@ -9189,14 +9367,14 @@
           </a:p>
           <a:p>
             <a:r>
-              <a:rPr lang="en-IN" sz="1500" b="1">
-                <a:latin typeface="Times New Roman"/>
-                <a:cs typeface="Times New Roman"/>
-              </a:rPr>
-              <a:t xml:space="preserve">• Live GPS Telemetry: </a:t>
-            </a:r>
-            <a:r>
-              <a:rPr lang="en-IN" sz="1500">
+              <a:rPr lang="en-IN" sz="1500" b="1" dirty="0">
+                <a:latin typeface="Times New Roman"/>
+                <a:cs typeface="Times New Roman"/>
+              </a:rPr>
+              <a:t xml:space="preserve">Live GPS Telemetry: </a:t>
+            </a:r>
+            <a:r>
+              <a:rPr lang="en-IN" sz="1500" dirty="0">
                 <a:latin typeface="Times New Roman"/>
                 <a:cs typeface="Times New Roman"/>
               </a:rPr>
@@ -9205,14 +9383,14 @@
           </a:p>
           <a:p>
             <a:r>
-              <a:rPr lang="en-IN" sz="1500" b="1">
-                <a:latin typeface="Times New Roman"/>
-                <a:cs typeface="Times New Roman"/>
-              </a:rPr>
-              <a:t xml:space="preserve">• Segment History: </a:t>
-            </a:r>
-            <a:r>
-              <a:rPr lang="en-IN" sz="1500">
+              <a:rPr lang="en-IN" sz="1500" b="1" dirty="0">
+                <a:latin typeface="Times New Roman"/>
+                <a:cs typeface="Times New Roman"/>
+              </a:rPr>
+              <a:t xml:space="preserve">Segment History: </a:t>
+            </a:r>
+            <a:r>
+              <a:rPr lang="en-IN" sz="1500" dirty="0">
                 <a:latin typeface="Times New Roman"/>
                 <a:cs typeface="Times New Roman"/>
               </a:rPr>
@@ -9221,14 +9399,14 @@
           </a:p>
           <a:p>
             <a:r>
-              <a:rPr lang="en-IN" sz="1500" b="1">
-                <a:latin typeface="Times New Roman"/>
-                <a:cs typeface="Times New Roman"/>
-              </a:rPr>
-              <a:t xml:space="preserve">• Spatial Polylines: </a:t>
-            </a:r>
-            <a:r>
-              <a:rPr lang="en-IN" sz="1500">
+              <a:rPr lang="en-IN" sz="1500" b="1" dirty="0">
+                <a:latin typeface="Times New Roman"/>
+                <a:cs typeface="Times New Roman"/>
+              </a:rPr>
+              <a:t xml:space="preserve">Spatial Polylines: </a:t>
+            </a:r>
+            <a:r>
+              <a:rPr lang="en-IN" sz="1500" dirty="0">
                 <a:latin typeface="Times New Roman"/>
                 <a:cs typeface="Times New Roman"/>
               </a:rPr>
@@ -9419,14 +9597,14 @@
           <a:lstStyle/>
           <a:p>
             <a:r>
-              <a:rPr lang="en-IN" sz="1500" b="1">
-                <a:latin typeface="Times New Roman"/>
-                <a:cs typeface="Times New Roman"/>
-              </a:rPr>
-              <a:t xml:space="preserve">• Client Tracking Loop: </a:t>
-            </a:r>
-            <a:r>
-              <a:rPr lang="en-IN" sz="1500">
+              <a:rPr lang="en-IN" sz="1500" b="1" dirty="0">
+                <a:latin typeface="Times New Roman"/>
+                <a:cs typeface="Times New Roman"/>
+              </a:rPr>
+              <a:t xml:space="preserve">Client Tracking Loop: </a:t>
+            </a:r>
+            <a:r>
+              <a:rPr lang="en-IN" sz="1500" dirty="0">
                 <a:latin typeface="Times New Roman"/>
                 <a:cs typeface="Times New Roman"/>
               </a:rPr>
@@ -9435,44 +9613,21 @@
           </a:p>
           <a:p>
             <a:r>
-              <a:rPr lang="en-IN" sz="1500" b="1">
-                <a:latin typeface="Times New Roman"/>
-                <a:cs typeface="Times New Roman"/>
-              </a:rPr>
-              <a:t xml:space="preserve">• Flowchart Code: </a:t>
-            </a:r>
-            <a:r>
-              <a:rPr lang="en-IN" sz="1500">
-                <a:latin typeface="Times New Roman"/>
-                <a:cs typeface="Times New Roman"/>
-              </a:rPr>
-              <a:t>See Mermaid notation below for visualization rendering:</a:t>
-            </a:r>
-          </a:p>
-          <a:p>
-            <a:r>
-              <a:rPr lang="en-IN" sz="1500" b="1">
-                <a:latin typeface="Times New Roman"/>
-                <a:cs typeface="Times New Roman"/>
-              </a:rPr>
-              <a:t>```mermaid
-</a:t>
-            </a:r>
-            <a:r>
-              <a:rPr lang="en-IN" sz="1500">
-                <a:latin typeface="Times New Roman"/>
-                <a:cs typeface="Times New Roman"/>
-              </a:rPr>
-              <a:t>graph TD
-    A[Driver Starts Trip] --&gt; B[Broadcast Coordinates]
-    B --&gt; C{Monotonic Filter Passed?}
-    C -- Yes --&gt; D[Update Cache &amp; Database]
-    C -- No --&gt; B
-    D --&gt; E[Blended ETA Engine]
-    E --&gt; F[API Endpoint Update]
-    F --&gt; G[Passenger Portal Renders Map]
-```</a:t>
-            </a:r>
+              <a:rPr lang="en-IN" sz="1500" b="1" dirty="0">
+                <a:latin typeface="Times New Roman"/>
+                <a:cs typeface="Times New Roman"/>
+              </a:rPr>
+              <a:t>Flowchart:</a:t>
+            </a:r>
+          </a:p>
+          <a:p>
+            <a:pPr marL="0" indent="0">
+              <a:buNone/>
+            </a:pPr>
+            <a:endParaRPr lang="en-IN" sz="1500" dirty="0">
+              <a:latin typeface="Times New Roman"/>
+              <a:cs typeface="Times New Roman"/>
+            </a:endParaRPr>
           </a:p>
         </p:txBody>
       </p:sp>
@@ -9573,6 +9728,36 @@
           <a:ln>
             <a:noFill/>
           </a:ln>
+        </p:spPr>
+      </p:pic>
+      <p:pic>
+        <p:nvPicPr>
+          <p:cNvPr id="7" name="Picture 6">
+            <a:extLst>
+              <a:ext uri="{FF2B5EF4-FFF2-40B4-BE49-F238E27FC236}">
+                <a16:creationId xmlns:a16="http://schemas.microsoft.com/office/drawing/2014/main" id="{D9BB392E-0D40-2D24-E949-D97D2CE3EED9}"/>
+              </a:ext>
+            </a:extLst>
+          </p:cNvPr>
+          <p:cNvPicPr>
+            <a:picLocks noChangeAspect="1"/>
+          </p:cNvPicPr>
+          <p:nvPr/>
+        </p:nvPicPr>
+        <p:blipFill>
+          <a:blip r:embed="rId3"/>
+          <a:stretch>
+            <a:fillRect/>
+          </a:stretch>
+        </p:blipFill>
+        <p:spPr>
+          <a:xfrm>
+            <a:off x="2798064" y="2201106"/>
+            <a:ext cx="5205161" cy="4656894"/>
+          </a:xfrm>
+          <a:prstGeom prst="rect">
+            <a:avLst/>
+          </a:prstGeom>
         </p:spPr>
       </p:pic>
     </p:spTree>

</xml_diff>